<commit_message>
tocmaker: size icons by native aspect ratio; refresh examples and skill notes
Co-Authored-By: Claude Fable 5.1 <noreply@anthropic.com>
Claude-Session: https://claude.ai/code/session_01S9icJDk5oZKC39S17dGdie
</commit_message>
<xml_diff>
--- a/tocmaker/examples/flow.pptx
+++ b/tocmaker/examples/flow.pptx
@@ -3758,8 +3758,8 @@
         </p:blipFill>
         <p:spPr>
           <a:xfrm>
-            <a:off x="88900" y="298443"/>
-            <a:ext cx="298973" cy="298973"/>
+            <a:off x="81617" y="294801"/>
+            <a:ext cx="306256" cy="306256"/>
           </a:xfrm>
           <a:prstGeom prst="rect">
             <a:avLst/>
@@ -3788,8 +3788,8 @@
         </p:blipFill>
         <p:spPr>
           <a:xfrm>
-            <a:off x="413273" y="298443"/>
-            <a:ext cx="298973" cy="298973"/>
+            <a:off x="413273" y="294801"/>
+            <a:ext cx="306256" cy="306256"/>
           </a:xfrm>
           <a:prstGeom prst="rect">
             <a:avLst/>
@@ -3986,8 +3986,8 @@
         </p:blipFill>
         <p:spPr>
           <a:xfrm>
-            <a:off x="1174227" y="463289"/>
-            <a:ext cx="298973" cy="298973"/>
+            <a:off x="1165260" y="458805"/>
+            <a:ext cx="307940" cy="307940"/>
           </a:xfrm>
           <a:prstGeom prst="rect">
             <a:avLst/>
@@ -4016,8 +4016,8 @@
         </p:blipFill>
         <p:spPr>
           <a:xfrm>
-            <a:off x="1498600" y="463289"/>
-            <a:ext cx="298973" cy="298973"/>
+            <a:off x="1498600" y="458805"/>
+            <a:ext cx="307940" cy="307940"/>
           </a:xfrm>
           <a:prstGeom prst="rect">
             <a:avLst/>

</xml_diff>